<commit_message>
Adopt grid-validated filter parameters from the 2026-09-04 session
tune_filter.py on calibration 1788433311 + stationary 1788430472 + moving
1788431407 (measured 617.5 mm move): retained 99.7%, endpoint 4.8 mm,
return 10.4 mm. Rest 30/3/1.5mm/1.0deg/4 checks/100 fallback; display
window 5, radius 0.20 m, dead zones 20 mm/0.3 deg, smoothing 1.2 s,
prior 2 s, endpoint window 3, re-anchor floor 40 mm/3 deg. Deck updated.

Co-Authored-By: Claude Fable 5 <noreply@anthropic.com>
</commit_message>
<xml_diff>
--- a/docs/Quest_Avatar_Placement_Algorithm_NaReT_Current_2026-09-05.pptx
+++ b/docs/Quest_Avatar_Placement_Algorithm_NaReT_Current_2026-09-05.pptx
@@ -276,7 +276,7 @@
           <a:p>
             <a:fld id="{40627236-4C34-48E2-B38E-25D0C5A8811C}" type="datetimeFigureOut">
               <a:rPr lang="en-GB" smtClean="0"/>
-              <a:t>02/09/2026</a:t>
+              <a:t>05/09/2026</a:t>
             </a:fld>
             <a:endParaRPr lang="en-GB"/>
           </a:p>
@@ -476,7 +476,7 @@
           <a:p>
             <a:fld id="{40627236-4C34-48E2-B38E-25D0C5A8811C}" type="datetimeFigureOut">
               <a:rPr lang="en-GB" smtClean="0"/>
-              <a:t>02/09/2026</a:t>
+              <a:t>05/09/2026</a:t>
             </a:fld>
             <a:endParaRPr lang="en-GB"/>
           </a:p>
@@ -686,7 +686,7 @@
           <a:p>
             <a:fld id="{40627236-4C34-48E2-B38E-25D0C5A8811C}" type="datetimeFigureOut">
               <a:rPr lang="en-GB" smtClean="0"/>
-              <a:t>02/09/2026</a:t>
+              <a:t>05/09/2026</a:t>
             </a:fld>
             <a:endParaRPr lang="en-GB"/>
           </a:p>
@@ -886,7 +886,7 @@
           <a:p>
             <a:fld id="{40627236-4C34-48E2-B38E-25D0C5A8811C}" type="datetimeFigureOut">
               <a:rPr lang="en-GB" smtClean="0"/>
-              <a:t>02/09/2026</a:t>
+              <a:t>05/09/2026</a:t>
             </a:fld>
             <a:endParaRPr lang="en-GB"/>
           </a:p>
@@ -1162,7 +1162,7 @@
           <a:p>
             <a:fld id="{40627236-4C34-48E2-B38E-25D0C5A8811C}" type="datetimeFigureOut">
               <a:rPr lang="en-GB" smtClean="0"/>
-              <a:t>02/09/2026</a:t>
+              <a:t>05/09/2026</a:t>
             </a:fld>
             <a:endParaRPr lang="en-GB"/>
           </a:p>
@@ -1430,7 +1430,7 @@
           <a:p>
             <a:fld id="{40627236-4C34-48E2-B38E-25D0C5A8811C}" type="datetimeFigureOut">
               <a:rPr lang="en-GB" smtClean="0"/>
-              <a:t>02/09/2026</a:t>
+              <a:t>05/09/2026</a:t>
             </a:fld>
             <a:endParaRPr lang="en-GB"/>
           </a:p>
@@ -1845,7 +1845,7 @@
           <a:p>
             <a:fld id="{40627236-4C34-48E2-B38E-25D0C5A8811C}" type="datetimeFigureOut">
               <a:rPr lang="en-GB" smtClean="0"/>
-              <a:t>02/09/2026</a:t>
+              <a:t>05/09/2026</a:t>
             </a:fld>
             <a:endParaRPr lang="en-GB"/>
           </a:p>
@@ -1987,7 +1987,7 @@
           <a:p>
             <a:fld id="{40627236-4C34-48E2-B38E-25D0C5A8811C}" type="datetimeFigureOut">
               <a:rPr lang="en-GB" smtClean="0"/>
-              <a:t>02/09/2026</a:t>
+              <a:t>05/09/2026</a:t>
             </a:fld>
             <a:endParaRPr lang="en-GB"/>
           </a:p>
@@ -2100,7 +2100,7 @@
           <a:p>
             <a:fld id="{40627236-4C34-48E2-B38E-25D0C5A8811C}" type="datetimeFigureOut">
               <a:rPr lang="en-GB" smtClean="0"/>
-              <a:t>02/09/2026</a:t>
+              <a:t>05/09/2026</a:t>
             </a:fld>
             <a:endParaRPr lang="en-GB"/>
           </a:p>
@@ -2413,7 +2413,7 @@
           <a:p>
             <a:fld id="{40627236-4C34-48E2-B38E-25D0C5A8811C}" type="datetimeFigureOut">
               <a:rPr lang="en-GB" smtClean="0"/>
-              <a:t>02/09/2026</a:t>
+              <a:t>05/09/2026</a:t>
             </a:fld>
             <a:endParaRPr lang="en-GB"/>
           </a:p>
@@ -2702,7 +2702,7 @@
           <a:p>
             <a:fld id="{40627236-4C34-48E2-B38E-25D0C5A8811C}" type="datetimeFigureOut">
               <a:rPr lang="en-GB" smtClean="0"/>
-              <a:t>02/09/2026</a:t>
+              <a:t>05/09/2026</a:t>
             </a:fld>
             <a:endParaRPr lang="en-GB"/>
           </a:p>
@@ -2945,7 +2945,7 @@
           <a:p>
             <a:fld id="{40627236-4C34-48E2-B38E-25D0C5A8811C}" type="datetimeFigureOut">
               <a:rPr lang="en-GB" smtClean="0"/>
-              <a:t>02/09/2026</a:t>
+              <a:t>05/09/2026</a:t>
             </a:fld>
             <a:endParaRPr lang="en-GB"/>
           </a:p>
@@ -5404,7 +5404,7 @@
                 </a:solidFill>
                 <a:latin typeface="Aptos" panose="020B0004020202020204" pitchFamily="34" charset="0"/>
               </a:rPr>
-              <a:t>40 / 5 / 100</a:t>
+              <a:t>30 / 3 / 100</a:t>
             </a:r>
           </a:p>
         </p:txBody>
@@ -5652,7 +5652,7 @@
                 </a:solidFill>
                 <a:latin typeface="Aptos" panose="020B0004020202020204" pitchFamily="34" charset="0"/>
               </a:rPr>
-              <a:t>7 • 0.10 m • 5 mm / 1.5° • 0.8 s</a:t>
+              <a:t>5 • 0.20 m • 20 mm / 0.3° • 1.2 s</a:t>
             </a:r>
           </a:p>
         </p:txBody>
@@ -5900,7 +5900,7 @@
                 </a:solidFill>
                 <a:latin typeface="Aptos" panose="020B0004020202020204" pitchFamily="34" charset="0"/>
               </a:rPr>
-              <a:t>8 s • 20 mm / 6°</a:t>
+              <a:t>2 s • 40 mm / 3°</a:t>
             </a:r>
           </a:p>
         </p:txBody>
@@ -5962,7 +5962,7 @@
                 </a:solidFill>
                 <a:latin typeface="Aptos" panose="020B0004020202020204" pitchFamily="34" charset="0"/>
               </a:rPr>
-              <a:t>Retained</a:t>
+              <a:t>Selected*</a:t>
             </a:r>
           </a:p>
         </p:txBody>
@@ -12246,7 +12246,7 @@
         </p:nvCxnSpPr>
         <p:spPr>
           <a:xfrm>
-            <a:off x="2159000" y="3175000"/>
+            <a:off x="2120900" y="3176032"/>
             <a:ext cx="2616200" cy="355600"/>
           </a:xfrm>
           <a:prstGeom prst="straightConnector1">
@@ -12288,7 +12288,7 @@
         </p:nvCxnSpPr>
         <p:spPr>
           <a:xfrm flipV="1">
-            <a:off x="2159000" y="3886200"/>
+            <a:off x="2066946" y="3657600"/>
             <a:ext cx="2616200" cy="812800"/>
           </a:xfrm>
           <a:prstGeom prst="straightConnector1">
@@ -12466,7 +12466,7 @@
           <a:lstStyle/>
           <a:p>
             <a:r>
-              <a:rPr lang="fr-FR" b="1">
+              <a:rPr lang="fr-FR" b="1" dirty="0">
                 <a:solidFill>
                   <a:srgbClr val="102A43"/>
                 </a:solidFill>
@@ -12474,7 +12474,7 @@
               </a:rPr>
               <a:t>Pose = position (X,Y,Z) + orientation</a:t>
             </a:r>
-            <a:endParaRPr lang="en-GB" b="1">
+            <a:endParaRPr lang="en-GB" b="1" dirty="0">
               <a:solidFill>
                 <a:srgbClr val="102A43"/>
               </a:solidFill>
@@ -12574,7 +12574,7 @@
           <a:p>
             <a:pPr algn="ctr"/>
             <a:r>
-              <a:rPr lang="en-GB" sz="1500" b="1">
+              <a:rPr lang="en-GB" sz="1500" b="1" dirty="0">
                 <a:solidFill>
                   <a:srgbClr val="16324F"/>
                 </a:solidFill>
@@ -12773,7 +12773,7 @@
           <a:lstStyle/>
           <a:p>
             <a:r>
-              <a:rPr lang="en-GB" sz="2800" b="1">
+              <a:rPr lang="en-GB" sz="2800" b="1" dirty="0">
                 <a:solidFill>
                   <a:srgbClr val="102A43"/>
                 </a:solidFill>
@@ -12866,8 +12866,8 @@
         </p:nvSpPr>
         <p:spPr>
           <a:xfrm>
-            <a:off x="533400" y="1549400"/>
-            <a:ext cx="9652000" cy="276999"/>
+            <a:off x="533399" y="1549401"/>
+            <a:ext cx="11605413" cy="276999"/>
           </a:xfrm>
           <a:prstGeom prst="rect">
             <a:avLst/>
@@ -12875,13 +12875,13 @@
           <a:noFill/>
         </p:spPr>
         <p:txBody>
-          <a:bodyPr vert="horz" lIns="0" tIns="0" rIns="0" bIns="0" rtlCol="0" anchor="t">
+          <a:bodyPr vert="horz" wrap="square" lIns="0" tIns="0" rIns="0" bIns="0" rtlCol="0" anchor="t">
             <a:spAutoFit/>
           </a:bodyPr>
           <a:lstStyle/>
           <a:p>
             <a:r>
-              <a:rPr lang="en-GB" b="1">
+              <a:rPr lang="en-GB" b="1" dirty="0">
                 <a:solidFill>
                   <a:srgbClr val="16324F"/>
                 </a:solidFill>
@@ -13067,7 +13067,7 @@
           <a:p>
             <a:pPr algn="ctr"/>
             <a:r>
-              <a:rPr lang="en-GB" sz="1600" b="1">
+              <a:rPr lang="en-GB" sz="1600" b="1" dirty="0">
                 <a:solidFill>
                   <a:srgbClr val="FFFFFF"/>
                 </a:solidFill>
@@ -13191,7 +13191,7 @@
           <a:p>
             <a:pPr algn="ctr"/>
             <a:r>
-              <a:rPr lang="en-GB" sz="1600" b="1">
+              <a:rPr lang="en-GB" sz="1600" b="1" dirty="0">
                 <a:solidFill>
                   <a:srgbClr val="FFFFFF"/>
                 </a:solidFill>
@@ -13440,7 +13440,7 @@
           </a:fontRef>
         </p:style>
         <p:txBody>
-          <a:bodyPr rtlCol="0" anchor="ctr" lIns="164592" rIns="128016" tIns="118872" bIns="91440"/>
+          <a:bodyPr lIns="164592" tIns="118872" rIns="128016" bIns="91440" rtlCol="0" anchor="ctr"/>
           <a:lstStyle/>
           <a:p>
             <a:pPr algn="l">
@@ -13496,15 +13496,12 @@
                 <a:spcPts val="0"/>
               </a:spcAft>
             </a:pPr>
-            <a:r>
-              <a:rPr sz="1350">
-                <a:solidFill>
-                  <a:srgbClr val="16324F"/>
-                </a:solidFill>
-                <a:latin typeface="Aptos"/>
-              </a:rPr>
-              <a:t/>
-            </a:r>
+            <a:endParaRPr sz="1350">
+              <a:solidFill>
+                <a:srgbClr val="16324F"/>
+              </a:solidFill>
+              <a:latin typeface="Aptos"/>
+            </a:endParaRPr>
           </a:p>
           <a:p>
             <a:pPr algn="l">
@@ -13807,7 +13804,7 @@
                 </a:solidFill>
                 <a:latin typeface="Aptos" panose="020B0004020202020204" pitchFamily="34" charset="0"/>
               </a:rPr>
-              <a:t>40</a:t>
+              <a:t>30</a:t>
             </a:r>
           </a:p>
         </p:txBody>
@@ -13952,7 +13949,7 @@
                 </a:solidFill>
                 <a:latin typeface="Aptos" panose="020B0004020202020204" pitchFamily="34" charset="0"/>
               </a:rPr>
-              <a:t>45</a:t>
+              <a:t>33</a:t>
             </a:r>
           </a:p>
         </p:txBody>
@@ -14097,7 +14094,7 @@
                 </a:solidFill>
                 <a:latin typeface="Aptos" panose="020B0004020202020204" pitchFamily="34" charset="0"/>
               </a:rPr>
-              <a:t>50</a:t>
+              <a:t>36</a:t>
             </a:r>
           </a:p>
         </p:txBody>
@@ -14242,7 +14239,7 @@
                 </a:solidFill>
                 <a:latin typeface="Aptos" panose="020B0004020202020204" pitchFamily="34" charset="0"/>
               </a:rPr>
-              <a:t>55</a:t>
+              <a:t>39</a:t>
             </a:r>
           </a:p>
         </p:txBody>
@@ -14318,7 +14315,7 @@
           <a:p>
             <a:pPr algn="ctr"/>
             <a:r>
-              <a:rPr lang="en-GB" sz="1600">
+              <a:rPr lang="en-GB" sz="1600" dirty="0">
                 <a:solidFill>
                   <a:srgbClr val="16324F"/>
                 </a:solidFill>
@@ -14397,40 +14394,13 @@
               </a:rPr>
             </a:br>
             <a:r>
-              <a:rPr lang="el-GR" sz="1600" b="1" dirty="0">
+              <a:rPr lang="en-GB" sz="1600" b="1" dirty="0">
                 <a:solidFill>
                   <a:srgbClr val="16324F"/>
                 </a:solidFill>
                 <a:latin typeface="Aptos" panose="020B0004020202020204" pitchFamily="34" charset="0"/>
               </a:rPr>
-              <a:t>Δ </a:t>
-            </a:r>
-            <a:r>
-              <a:rPr lang="en-GB" sz="1600" b="1" dirty="0">
-                <a:solidFill>
-                  <a:srgbClr val="16324F"/>
-                </a:solidFill>
-                <a:latin typeface="Aptos" panose="020B0004020202020204" pitchFamily="34" charset="0"/>
-              </a:rPr>
-              <a:t>position ≤ 2 mm  AND  </a:t>
-            </a:r>
-            <a:r>
-              <a:rPr lang="el-GR" sz="1600" b="1" dirty="0">
-                <a:solidFill>
-                  <a:srgbClr val="16324F"/>
-                </a:solidFill>
-                <a:latin typeface="Aptos" panose="020B0004020202020204" pitchFamily="34" charset="0"/>
-              </a:rPr>
-              <a:t>Δ </a:t>
-            </a:r>
-            <a:r>
-              <a:rPr lang="en-GB" sz="1600" b="1" dirty="0">
-                <a:solidFill>
-                  <a:srgbClr val="16324F"/>
-                </a:solidFill>
-                <a:latin typeface="Aptos" panose="020B0004020202020204" pitchFamily="34" charset="0"/>
-              </a:rPr>
-              <a:t>rotation ≤ 0.5°</a:t>
+              <a:t>Δ position ≤ 1.5 mm  AND  Δ rotation ≤ 1.0°</a:t>
             </a:r>
           </a:p>
         </p:txBody>
@@ -14492,7 +14462,7 @@
                 </a:solidFill>
                 <a:latin typeface="Aptos" panose="020B0004020202020204" pitchFamily="34" charset="0"/>
               </a:rPr>
-              <a:t>3 stable comparisons → detection 55</a:t>
+              <a:t>4 stable comparisons → detection 42 earliest</a:t>
             </a:r>
             <a:br>
               <a:rPr lang="en-GB" sz="1500" b="1" dirty="0">
@@ -14502,6 +14472,15 @@
                 <a:latin typeface="Aptos" panose="020B0004020202020204" pitchFamily="34" charset="0"/>
               </a:rPr>
             </a:br>
+            <a:r>
+              <a:rPr lang="en-GB" sz="1500" b="1" dirty="0">
+                <a:solidFill>
+                  <a:srgbClr val="202C37"/>
+                </a:solidFill>
+                <a:latin typeface="Aptos" panose="020B0004020202020204" pitchFamily="34" charset="0"/>
+              </a:rPr>
+              <a:t/>
+            </a:r>
             <a:br>
               <a:rPr lang="en-GB" sz="1500" b="1" dirty="0">
                 <a:solidFill>
@@ -14517,7 +14496,7 @@
                 </a:solidFill>
                 <a:latin typeface="Aptos" panose="020B0004020202020204" pitchFamily="34" charset="0"/>
               </a:rPr>
-              <a:t>Detection 100 fallback ≈20 s</a:t>
+              <a:t>Detection 100 fallback ≈ 10 s at 10 Hz</a:t>
             </a:r>
           </a:p>
         </p:txBody>
@@ -14557,7 +14536,7 @@
                 </a:solidFill>
                 <a:latin typeface="Aptos" panose="020B0004020202020204" pitchFamily="34" charset="0"/>
               </a:rPr>
-              <a:t>Grid-selected on both calibration replays • 95–97% stationary confirmation • 0% moving false acceptance</a:t>
+              <a:t>Grid-selected on the 2026-09-04 session • ≥95% stationary confirmation • ≤5% moving false acceptance</a:t>
             </a:r>
           </a:p>
         </p:txBody>
@@ -15091,7 +15070,7 @@
                 </a:solidFill>
                 <a:latin typeface="Aptos" panose="020B0004020202020204" pitchFamily="34" charset="0"/>
               </a:rPr>
-              <a:t>7-POSE</a:t>
+              <a:t>5-POSE</a:t>
             </a:r>
             <a:br>
               <a:rPr lang="en-GB" sz="1400" b="1">
@@ -15936,16 +15915,7 @@
                 </a:solidFill>
                 <a:latin typeface="Aptos" panose="020B0004020202020204" pitchFamily="34" charset="0"/>
               </a:rPr>
-              <a:t>Selected values: window 7 • radius 0.10 m • position dead zone 5 mm • rotation dead zone 1.5° • smoothing τ = 0.8 s • prior τ = 8 s • </a:t>
-            </a:r>
-            <a:r>
-              <a:rPr lang="en-GB" sz="1600" b="1" dirty="0">
-                <a:solidFill>
-                  <a:srgbClr val="FF0000"/>
-                </a:solidFill>
-                <a:latin typeface="Aptos" panose="020B0004020202020204" pitchFamily="34" charset="0"/>
-              </a:rPr>
-              <a:t>rest re-anchor beyond 20 mm / 6°</a:t>
+              <a:t>Selected values: window 5 • radius 0.20 m • position dead zone 20 mm • rotation dead zone 0.3° • smoothing τ = 1.2 s • prior τ = 2 s • rest re-anchor beyond 40 mm / 3°</a:t>
             </a:r>
           </a:p>
         </p:txBody>
@@ -16144,7 +16114,7 @@
                 </a:solidFill>
                 <a:latin typeface="Aptos" panose="020B0004020202020204" pitchFamily="34" charset="0"/>
               </a:rPr>
-              <a:t>Why the seven-pose medoid rejects jumps</a:t>
+              <a:t>Why the five-pose medoid rejects jumps</a:t>
             </a:r>
           </a:p>
         </p:txBody>
@@ -16805,7 +16775,7 @@
                 </a:solidFill>
                 <a:latin typeface="Aptos" panose="020B0004020202020204" pitchFamily="34" charset="0"/>
               </a:rPr>
-              <a:t>Current radius = 0.10 m</a:t>
+              <a:t>Selected radius = 0.20 m</a:t>
             </a:r>
             <a:br>
               <a:rPr lang="en-GB" sz="1600">
@@ -16815,6 +16785,15 @@
                 <a:latin typeface="Aptos" panose="020B0004020202020204" pitchFamily="34" charset="0"/>
               </a:rPr>
             </a:br>
+            <a:r>
+              <a:rPr lang="en-GB" sz="1600">
+                <a:solidFill>
+                  <a:srgbClr val="16324F"/>
+                </a:solidFill>
+                <a:latin typeface="Aptos" panose="020B0004020202020204" pitchFamily="34" charset="0"/>
+              </a:rPr>
+              <a:t/>
+            </a:r>
             <a:br>
               <a:rPr lang="en-GB" sz="1600">
                 <a:solidFill>
@@ -16830,7 +16809,7 @@
                 </a:solidFill>
                 <a:latin typeface="Aptos" panose="020B0004020202020204" pitchFamily="34" charset="0"/>
               </a:rPr>
-              <a:t>At this radius, 1° rotation contributes approximately the same score as 1.75 mm of position error.</a:t>
+              <a:t>At this radius, 1° rotation contributes approximately the same score as 3.5 mm of position error.</a:t>
             </a:r>
           </a:p>
         </p:txBody>
@@ -16870,7 +16849,7 @@
                 </a:solidFill>
                 <a:latin typeface="Aptos" panose="020B0004020202020204" pitchFamily="34" charset="0"/>
               </a:rPr>
-              <a:t>simple_pose_stabilizer.gd::_medoid • 0.10 m selected across old/new calibration replays</a:t>
+              <a:t>simple_pose_stabilizer.gd::_medoid • 0.20 m selected on the 2026-09-04 session replays</a:t>
             </a:r>
           </a:p>
         </p:txBody>
@@ -17221,7 +17200,7 @@
                 </a:solidFill>
                 <a:latin typeface="Aptos" panose="020B0004020202020204" pitchFamily="34" charset="0"/>
               </a:rPr>
-              <a:t>≤5 mm position</a:t>
+              <a:t>≤20 mm position</a:t>
             </a:r>
             <a:br>
               <a:rPr lang="en-GB" sz="1600">
@@ -17238,7 +17217,7 @@
                 </a:solidFill>
                 <a:latin typeface="Aptos" panose="020B0004020202020204" pitchFamily="34" charset="0"/>
               </a:rPr>
-              <a:t>≤1.5° rotation</a:t>
+              <a:t>≤0.3° rotation</a:t>
             </a:r>
             <a:br>
               <a:rPr lang="en-GB" sz="1600">
@@ -17248,6 +17227,15 @@
                 <a:latin typeface="Aptos" panose="020B0004020202020204" pitchFamily="34" charset="0"/>
               </a:rPr>
             </a:br>
+            <a:r>
+              <a:rPr lang="en-GB" sz="1600">
+                <a:solidFill>
+                  <a:srgbClr val="16324F"/>
+                </a:solidFill>
+                <a:latin typeface="Aptos" panose="020B0004020202020204" pitchFamily="34" charset="0"/>
+              </a:rPr>
+              <a:t/>
+            </a:r>
             <a:br>
               <a:rPr lang="en-GB" sz="1600">
                 <a:solidFill>
@@ -17387,33 +17375,59 @@
                 </a:solidFill>
                 <a:latin typeface="Aptos" panose="020B0004020202020204" pitchFamily="34" charset="0"/>
               </a:rPr>
-              <a:t>τ = 0.8 </a:t>
-            </a:r>
-            <a:r>
-              <a:rPr lang="en-GB" sz="1600" dirty="0">
+              <a:t>τ = 1.2 s</a:t>
+            </a:r>
+            <a:br>
+              <a:rPr lang="el-GR" sz="1600" dirty="0">
                 <a:solidFill>
                   <a:srgbClr val="16324F"/>
                 </a:solidFill>
                 <a:latin typeface="Aptos" panose="020B0004020202020204" pitchFamily="34" charset="0"/>
               </a:rPr>
-              <a:t>s</a:t>
+            </a:br>
+            <a:r>
+              <a:rPr lang="el-GR" sz="1600" dirty="0">
+                <a:solidFill>
+                  <a:srgbClr val="16324F"/>
+                </a:solidFill>
+                <a:latin typeface="Aptos" panose="020B0004020202020204" pitchFamily="34" charset="0"/>
+              </a:rPr>
+              <a:t/>
             </a:r>
             <a:br>
-              <a:rPr lang="en-GB" sz="1600" dirty="0">
+              <a:rPr lang="el-GR" sz="1600" dirty="0">
                 <a:solidFill>
                   <a:srgbClr val="16324F"/>
                 </a:solidFill>
                 <a:latin typeface="Aptos" panose="020B0004020202020204" pitchFamily="34" charset="0"/>
               </a:rPr>
             </a:br>
+            <a:r>
+              <a:rPr lang="el-GR" sz="1600" dirty="0">
+                <a:solidFill>
+                  <a:srgbClr val="16324F"/>
+                </a:solidFill>
+                <a:latin typeface="Aptos" panose="020B0004020202020204" pitchFamily="34" charset="0"/>
+              </a:rPr>
+              <a:t>63% after 1.2 s</a:t>
+            </a:r>
             <a:br>
-              <a:rPr lang="en-GB" sz="1600" dirty="0">
+              <a:rPr lang="el-GR" sz="1600" dirty="0">
                 <a:solidFill>
                   <a:srgbClr val="16324F"/>
                 </a:solidFill>
                 <a:latin typeface="Aptos" panose="020B0004020202020204" pitchFamily="34" charset="0"/>
               </a:rPr>
             </a:br>
+            <a:r>
+              <a:rPr lang="el-GR" sz="1600" dirty="0">
+                <a:solidFill>
+                  <a:srgbClr val="16324F"/>
+                </a:solidFill>
+                <a:latin typeface="Aptos" panose="020B0004020202020204" pitchFamily="34" charset="0"/>
+              </a:rPr>
+              <a:t>95% after 3.6 s</a:t>
+            </a:r>
             <a:endParaRPr lang="en-GB" sz="1600" dirty="0">
               <a:solidFill>
                 <a:srgbClr val="16324F"/>
@@ -17542,7 +17556,7 @@
                 </a:solidFill>
                 <a:latin typeface="Aptos" panose="020B0004020202020204" pitchFamily="34" charset="0"/>
               </a:rPr>
-              <a:t>τ = 8 s</a:t>
+              <a:t>τ = 2 s</a:t>
             </a:r>
             <a:br>
               <a:rPr lang="en-GB" sz="1600" dirty="0">
@@ -17552,6 +17566,15 @@
                 <a:latin typeface="Aptos" panose="020B0004020202020204" pitchFamily="34" charset="0"/>
               </a:rPr>
             </a:br>
+            <a:r>
+              <a:rPr lang="en-GB" sz="1600" dirty="0">
+                <a:solidFill>
+                  <a:srgbClr val="16324F"/>
+                </a:solidFill>
+                <a:latin typeface="Aptos" panose="020B0004020202020204" pitchFamily="34" charset="0"/>
+              </a:rPr>
+              <a:t/>
+            </a:r>
             <a:br>
               <a:rPr lang="en-GB" sz="1600" dirty="0">
                 <a:solidFill>
@@ -17563,11 +17586,11 @@
             <a:r>
               <a:rPr lang="en-GB" sz="1600" dirty="0">
                 <a:solidFill>
-                  <a:srgbClr val="FF0000"/>
-                </a:solidFill>
-                <a:latin typeface="Aptos" panose="020B0004020202020204" pitchFamily="34" charset="0"/>
-              </a:rPr>
-              <a:t>Weak and always active; smoothing is 10× faster, so measurements lead during movement.</a:t>
+                  <a:srgbClr val="16324F"/>
+                </a:solidFill>
+                <a:latin typeface="Aptos" panose="020B0004020202020204" pitchFamily="34" charset="0"/>
+              </a:rPr>
+              <a:t>Always active; after a re-anchor the landing rule closes onto the new rest at smoothing speed.</a:t>
             </a:r>
           </a:p>
         </p:txBody>
@@ -17608,7 +17631,7 @@
                 </a:solidFill>
                 <a:latin typeface="Aptos" panose="020B0004020202020204" pitchFamily="34" charset="0"/>
               </a:rPr>
-              <a:t>A stable endpoint beyond 20 mm or 6° re-anchors the remembered rest itself, so the prior pulls toward the new location instead of dragging a relocated mannequin backwards.</a:t>
+              <a:t>A stable endpoint beyond 40 mm or 3° re-anchors the remembered rest itself, so the prior pulls toward the new location instead of dragging a relocated mannequin backwards.</a:t>
             </a:r>
           </a:p>
         </p:txBody>
@@ -18058,7 +18081,7 @@
                 </a:solidFill>
                 <a:latin typeface="Aptos" panose="020B0004020202020204" pitchFamily="34" charset="0"/>
               </a:rPr>
-              <a:t>7-target window</a:t>
+              <a:t>3-target window</a:t>
             </a:r>
             <a:br>
               <a:rPr lang="en-GB" b="1">
@@ -18237,7 +18260,7 @@
                 </a:solidFill>
                 <a:latin typeface="Aptos" panose="020B0004020202020204" pitchFamily="34" charset="0"/>
               </a:rPr>
-              <a:t>Re-anchor floor: 20 mm / 6°</a:t>
+              <a:t>Re-anchor floor: 40 mm / 3°</a:t>
             </a:r>
           </a:p>
         </p:txBody>
@@ -18278,7 +18301,7 @@
                 </a:solidFill>
                 <a:latin typeface="Aptos" panose="020B0004020202020204" pitchFamily="34" charset="0"/>
               </a:rPr>
-              <a:t>Rest never learns from a single raw pose and never from the displayed pose, because that output already contains smoothing and prior feedback. It adopts the measurement-only medoid target once the complete 7-target window is stationary (≤2 mm / ≤0.5°) and clearly displaced from the old rest. Position and rotation re-anchor independently.</a:t>
+              <a:t>Rest never learns from a single raw pose and never from the displayed pose, because that output already contains smoothing and prior feedback. It adopts the measurement-only medoid target once the complete 3-target window is stationary (≤1.5 mm / ≤1.0°) and clearly displaced from the old rest. Position and rotation re-anchor independently.</a:t>
             </a:r>
           </a:p>
         </p:txBody>

</xml_diff>

<commit_message>
Add re-anchor chain and grid-method slides; fix values-bar overflow
Co-Authored-By: Claude Fable 5 <noreply@anthropic.com>
</commit_message>
<xml_diff>
--- a/docs/Quest_Avatar_Placement_Algorithm_NaReT_Current_2026-09-05.pptx
+++ b/docs/Quest_Avatar_Placement_Algorithm_NaReT_Current_2026-09-05.pptx
@@ -21,6 +21,8 @@
     <p:sldId id="270" r:id="rId15"/>
     <p:sldId id="271" r:id="rId16"/>
     <p:sldId id="272" r:id="rId17"/>
+    <p:sldId id="274" r:id="rId22"/>
+    <p:sldId id="275" r:id="rId23"/>
   </p:sldIdLst>
   <p:sldSz cx="12192000" cy="6858000"/>
   <p:notesSz cx="6858000" cy="9144000"/>
@@ -11782,6 +11784,700 @@
 </p:sld>
 </file>
 
+<file path=ppt/slides/slide17.xml><?xml version="1.0" encoding="utf-8"?>
+<p:sld xmlns:a="http://schemas.openxmlformats.org/drawingml/2006/main" xmlns:p="http://schemas.openxmlformats.org/presentationml/2006/main" xmlns:r="http://schemas.openxmlformats.org/officeDocument/2006/relationships">
+  <p:cSld>
+    <p:spTree>
+      <p:nvGrpSpPr>
+        <p:cNvPr id="1" name=""/>
+        <p:cNvGrpSpPr/>
+        <p:nvPr/>
+      </p:nvGrpSpPr>
+      <p:grpSpPr/>
+      <p:sp>
+        <p:nvSpPr>
+          <p:cNvPr id="2" name="TextBox 1"/>
+          <p:cNvSpPr txBox="1"/>
+          <p:nvPr/>
+        </p:nvSpPr>
+        <p:spPr>
+          <a:xfrm>
+            <a:off x="530352" y="256032"/>
+            <a:ext cx="7616952" cy="274320"/>
+          </a:xfrm>
+          <a:prstGeom prst="rect">
+            <a:avLst/>
+          </a:prstGeom>
+          <a:noFill/>
+        </p:spPr>
+        <p:txBody>
+          <a:bodyPr wrap="square">
+            <a:spAutoFit/>
+          </a:bodyPr>
+          <a:lstStyle/>
+          <a:p>
+            <a:pPr>
+              <a:spcAft>
+                <a:spcPts val="0"/>
+              </a:spcAft>
+            </a:pPr>
+            <a:r>
+              <a:rPr sz="1000" b="1">
+                <a:solidFill>
+                  <a:srgbClr val="5C7084"/>
+                </a:solidFill>
+                <a:latin typeface="Aptos"/>
+              </a:rPr>
+              <a:t>CURRENT QUEST RUNTIME</a:t>
+            </a:r>
+          </a:p>
+        </p:txBody>
+      </p:sp>
+      <p:sp>
+        <p:nvSpPr>
+          <p:cNvPr id="3" name="TextBox 2"/>
+          <p:cNvSpPr txBox="1"/>
+          <p:nvPr/>
+        </p:nvSpPr>
+        <p:spPr>
+          <a:xfrm>
+            <a:off x="530352" y="530352"/>
+            <a:ext cx="10981944" cy="502920"/>
+          </a:xfrm>
+          <a:prstGeom prst="rect">
+            <a:avLst/>
+          </a:prstGeom>
+          <a:noFill/>
+        </p:spPr>
+        <p:txBody>
+          <a:bodyPr wrap="square">
+            <a:spAutoFit/>
+          </a:bodyPr>
+          <a:lstStyle/>
+          <a:p>
+            <a:pPr>
+              <a:spcAft>
+                <a:spcPts val="0"/>
+              </a:spcAft>
+            </a:pPr>
+            <a:r>
+              <a:rPr sz="2400" b="1">
+                <a:solidFill>
+                  <a:srgbClr val="102A43"/>
+                </a:solidFill>
+                <a:latin typeface="Aptos"/>
+              </a:rPr>
+              <a:t>How a re-anchor happens - the exact chain</a:t>
+            </a:r>
+          </a:p>
+        </p:txBody>
+      </p:sp>
+      <p:sp>
+        <p:nvSpPr>
+          <p:cNvPr id="4" name="Rectangle 3"/>
+          <p:cNvSpPr/>
+          <p:nvPr/>
+        </p:nvSpPr>
+        <p:spPr>
+          <a:xfrm>
+            <a:off x="530352" y="1280160"/>
+            <a:ext cx="11128248" cy="36576"/>
+          </a:xfrm>
+          <a:prstGeom prst="rect">
+            <a:avLst/>
+          </a:prstGeom>
+          <a:solidFill>
+            <a:srgbClr val="102A43"/>
+          </a:solidFill>
+          <a:ln>
+            <a:noFill/>
+          </a:ln>
+        </p:spPr>
+        <p:style>
+          <a:lnRef idx="1">
+            <a:schemeClr val="accent1"/>
+          </a:lnRef>
+          <a:fillRef idx="3">
+            <a:schemeClr val="accent1"/>
+          </a:fillRef>
+          <a:effectRef idx="2">
+            <a:schemeClr val="accent1"/>
+          </a:effectRef>
+          <a:fontRef idx="minor">
+            <a:schemeClr val="lt1"/>
+          </a:fontRef>
+        </p:style>
+        <p:txBody>
+          <a:bodyPr rtlCol="0" anchor="ctr"/>
+          <a:lstStyle/>
+          <a:p>
+            <a:pPr algn="ctr"/>
+          </a:p>
+        </p:txBody>
+      </p:sp>
+      <p:sp>
+        <p:nvSpPr>
+          <p:cNvPr id="5" name="TextBox 4"/>
+          <p:cNvSpPr txBox="1"/>
+          <p:nvPr/>
+        </p:nvSpPr>
+        <p:spPr>
+          <a:xfrm>
+            <a:off x="11073384" y="6437376"/>
+            <a:ext cx="585216" cy="182880"/>
+          </a:xfrm>
+          <a:prstGeom prst="rect">
+            <a:avLst/>
+          </a:prstGeom>
+          <a:noFill/>
+        </p:spPr>
+        <p:txBody>
+          <a:bodyPr wrap="square">
+            <a:spAutoFit/>
+          </a:bodyPr>
+          <a:lstStyle/>
+          <a:p>
+            <a:pPr>
+              <a:spcAft>
+                <a:spcPts val="0"/>
+              </a:spcAft>
+            </a:pPr>
+            <a:r>
+              <a:rPr sz="800" b="0">
+                <a:solidFill>
+                  <a:srgbClr val="5C7084"/>
+                </a:solidFill>
+                <a:latin typeface="Aptos"/>
+              </a:rPr>
+              <a:t>17</a:t>
+            </a:r>
+          </a:p>
+        </p:txBody>
+      </p:sp>
+      <p:sp>
+        <p:nvSpPr>
+          <p:cNvPr id="6" name="TextBox 5"/>
+          <p:cNvSpPr txBox="1"/>
+          <p:nvPr/>
+        </p:nvSpPr>
+        <p:spPr>
+          <a:xfrm>
+            <a:off x="640080" y="1600200"/>
+            <a:ext cx="10881360" cy="3017520"/>
+          </a:xfrm>
+          <a:prstGeom prst="rect">
+            <a:avLst/>
+          </a:prstGeom>
+          <a:noFill/>
+        </p:spPr>
+        <p:txBody>
+          <a:bodyPr wrap="square">
+            <a:spAutoFit/>
+          </a:bodyPr>
+          <a:lstStyle/>
+          <a:p>
+            <a:pPr>
+              <a:spcAft>
+                <a:spcPts val="800"/>
+              </a:spcAft>
+            </a:pPr>
+            <a:r>
+              <a:rPr sz="1500" b="0">
+                <a:solidFill>
+                  <a:srgbClr val="16324F"/>
+                </a:solidFill>
+                <a:latin typeface="Aptos"/>
+              </a:rPr>
+              <a:t>1.  Every detection produces one fused, floor-locked pose.</a:t>
+            </a:r>
+          </a:p>
+          <a:p>
+            <a:pPr>
+              <a:spcAft>
+                <a:spcPts val="800"/>
+              </a:spcAft>
+            </a:pPr>
+            <a:r>
+              <a:rPr sz="1500" b="0">
+                <a:solidFill>
+                  <a:srgbClr val="16324F"/>
+                </a:solidFill>
+                <a:latin typeface="Aptos"/>
+              </a:rPr>
+              <a:t>2.  The window of the last 5 poses keeps a running MEDOID - one real measured pose, the most central. This measurement target is the markers' pure, unfiltered opinion: no dead zone, no smoothing, no prior.</a:t>
+            </a:r>
+          </a:p>
+          <a:p>
+            <a:pPr>
+              <a:spcAft>
+                <a:spcPts val="800"/>
+              </a:spcAft>
+            </a:pPr>
+            <a:r>
+              <a:rPr sz="1500" b="0">
+                <a:solidFill>
+                  <a:srgbClr val="16324F"/>
+                </a:solidFill>
+                <a:latin typeface="Aptos"/>
+              </a:rPr>
+              <a:t>3.  SETTLED test: the last 3 consecutive targets must all agree within 1.5 mm / 1.0° of the newest one - movement has provably stopped.</a:t>
+            </a:r>
+          </a:p>
+          <a:p>
+            <a:pPr>
+              <a:spcAft>
+                <a:spcPts val="800"/>
+              </a:spcAft>
+            </a:pPr>
+            <a:r>
+              <a:rPr sz="1500" b="0">
+                <a:solidFill>
+                  <a:srgbClr val="16324F"/>
+                </a:solidFill>
+                <a:latin typeface="Aptos"/>
+              </a:rPr>
+              <a:t>4.  DISTANCE test: the settled target must lie beyond 40 mm / 3° from the remembered rest - too far to be viewpoint bias.</a:t>
+            </a:r>
+          </a:p>
+          <a:p>
+            <a:pPr>
+              <a:spcAft>
+                <a:spcPts val="0"/>
+              </a:spcAft>
+            </a:pPr>
+            <a:r>
+              <a:rPr sz="1500" b="0">
+                <a:solidFill>
+                  <a:srgbClr val="16324F"/>
+                </a:solidFill>
+                <a:latin typeface="Aptos"/>
+              </a:rPr>
+              <a:t>5.  Both passed → the newest medoid target becomes the new rest, copied verbatim. Position and rotation re-anchor independently, once per detection.</a:t>
+            </a:r>
+          </a:p>
+        </p:txBody>
+      </p:sp>
+      <p:sp>
+        <p:nvSpPr>
+          <p:cNvPr id="7" name="Rounded Rectangle 6"/>
+          <p:cNvSpPr/>
+          <p:nvPr/>
+        </p:nvSpPr>
+        <p:spPr>
+          <a:xfrm>
+            <a:off x="822960" y="4892040"/>
+            <a:ext cx="10515600" cy="1234440"/>
+          </a:xfrm>
+          <a:prstGeom prst="roundRect">
+            <a:avLst/>
+          </a:prstGeom>
+          <a:solidFill>
+            <a:srgbClr val="E4EAF1"/>
+          </a:solidFill>
+          <a:ln>
+            <a:solidFill>
+              <a:srgbClr val="102A43"/>
+            </a:solidFill>
+          </a:ln>
+        </p:spPr>
+        <p:style>
+          <a:lnRef idx="1">
+            <a:schemeClr val="accent1"/>
+          </a:lnRef>
+          <a:fillRef idx="3">
+            <a:schemeClr val="accent1"/>
+          </a:fillRef>
+          <a:effectRef idx="2">
+            <a:schemeClr val="accent1"/>
+          </a:effectRef>
+          <a:fontRef idx="minor">
+            <a:schemeClr val="lt1"/>
+          </a:fontRef>
+        </p:style>
+        <p:txBody>
+          <a:bodyPr rtlCol="0" anchor="ctr" wrap="square"/>
+          <a:lstStyle/>
+          <a:p>
+            <a:pPr algn="ctr"/>
+            <a:r>
+              <a:rPr sz="1300">
+                <a:solidFill>
+                  <a:srgbClr val="16324F"/>
+                </a:solidFill>
+                <a:latin typeface="Aptos"/>
+              </a:rPr>
+              <a:t>What the new rest deliberately is NOT: not the displayed pose (it contains smoothing and prior feedback - learning from it would be a feedback loop); not a single raw detection (glitch risk); not an average of the settled window (only one real measured pose is ever adopted).</a:t>
+            </a:r>
+          </a:p>
+        </p:txBody>
+      </p:sp>
+      <p:sp>
+        <p:nvSpPr>
+          <p:cNvPr id="8" name="TextBox 7"/>
+          <p:cNvSpPr txBox="1"/>
+          <p:nvPr/>
+        </p:nvSpPr>
+        <p:spPr>
+          <a:xfrm>
+            <a:off x="530352" y="6473952"/>
+            <a:ext cx="9784080" cy="182880"/>
+          </a:xfrm>
+          <a:prstGeom prst="rect">
+            <a:avLst/>
+          </a:prstGeom>
+          <a:noFill/>
+        </p:spPr>
+        <p:txBody>
+          <a:bodyPr wrap="square">
+            <a:spAutoFit/>
+          </a:bodyPr>
+          <a:lstStyle/>
+          <a:p>
+            <a:pPr>
+              <a:spcAft>
+                <a:spcPts val="0"/>
+              </a:spcAft>
+            </a:pPr>
+            <a:r>
+              <a:rPr sz="800" b="0">
+                <a:solidFill>
+                  <a:srgbClr val="5C7084"/>
+                </a:solidFill>
+                <a:latin typeface="Aptos"/>
+              </a:rPr>
+              <a:t>navel_provider.gd::reanchor_rest_from_stable_target • SimplePoseStabilizer.measurement_target()</a:t>
+            </a:r>
+          </a:p>
+        </p:txBody>
+      </p:sp>
+    </p:spTree>
+  </p:cSld>
+  <p:clrMapOvr>
+    <a:masterClrMapping/>
+  </p:clrMapOvr>
+</p:sld>
+</file>
+
+<file path=ppt/slides/slide18.xml><?xml version="1.0" encoding="utf-8"?>
+<p:sld xmlns:a="http://schemas.openxmlformats.org/drawingml/2006/main" xmlns:p="http://schemas.openxmlformats.org/presentationml/2006/main" xmlns:r="http://schemas.openxmlformats.org/officeDocument/2006/relationships">
+  <p:cSld>
+    <p:spTree>
+      <p:nvGrpSpPr>
+        <p:cNvPr id="1" name=""/>
+        <p:cNvGrpSpPr/>
+        <p:nvPr/>
+      </p:nvGrpSpPr>
+      <p:grpSpPr/>
+      <p:sp>
+        <p:nvSpPr>
+          <p:cNvPr id="2" name="TextBox 1"/>
+          <p:cNvSpPr txBox="1"/>
+          <p:nvPr/>
+        </p:nvSpPr>
+        <p:spPr>
+          <a:xfrm>
+            <a:off x="530352" y="256032"/>
+            <a:ext cx="7616952" cy="274320"/>
+          </a:xfrm>
+          <a:prstGeom prst="rect">
+            <a:avLst/>
+          </a:prstGeom>
+          <a:noFill/>
+        </p:spPr>
+        <p:txBody>
+          <a:bodyPr wrap="square">
+            <a:spAutoFit/>
+          </a:bodyPr>
+          <a:lstStyle/>
+          <a:p>
+            <a:pPr>
+              <a:spcAft>
+                <a:spcPts val="0"/>
+              </a:spcAft>
+            </a:pPr>
+            <a:r>
+              <a:rPr sz="1000" b="1">
+                <a:solidFill>
+                  <a:srgbClr val="5C7084"/>
+                </a:solidFill>
+                <a:latin typeface="Aptos"/>
+              </a:rPr>
+              <a:t>CURRENT QUEST RUNTIME</a:t>
+            </a:r>
+          </a:p>
+        </p:txBody>
+      </p:sp>
+      <p:sp>
+        <p:nvSpPr>
+          <p:cNvPr id="3" name="TextBox 2"/>
+          <p:cNvSpPr txBox="1"/>
+          <p:nvPr/>
+        </p:nvSpPr>
+        <p:spPr>
+          <a:xfrm>
+            <a:off x="530352" y="530352"/>
+            <a:ext cx="10981944" cy="502920"/>
+          </a:xfrm>
+          <a:prstGeom prst="rect">
+            <a:avLst/>
+          </a:prstGeom>
+          <a:noFill/>
+        </p:spPr>
+        <p:txBody>
+          <a:bodyPr wrap="square">
+            <a:spAutoFit/>
+          </a:bodyPr>
+          <a:lstStyle/>
+          <a:p>
+            <a:pPr>
+              <a:spcAft>
+                <a:spcPts val="0"/>
+              </a:spcAft>
+            </a:pPr>
+            <a:r>
+              <a:rPr sz="2400" b="1">
+                <a:solidFill>
+                  <a:srgbClr val="102A43"/>
+                </a:solidFill>
+                <a:latin typeface="Aptos"/>
+              </a:rPr>
+              <a:t>How each value was selected - the grid method</a:t>
+            </a:r>
+          </a:p>
+        </p:txBody>
+      </p:sp>
+      <p:sp>
+        <p:nvSpPr>
+          <p:cNvPr id="4" name="Rectangle 3"/>
+          <p:cNvSpPr/>
+          <p:nvPr/>
+        </p:nvSpPr>
+        <p:spPr>
+          <a:xfrm>
+            <a:off x="530352" y="1280160"/>
+            <a:ext cx="11128248" cy="36576"/>
+          </a:xfrm>
+          <a:prstGeom prst="rect">
+            <a:avLst/>
+          </a:prstGeom>
+          <a:solidFill>
+            <a:srgbClr val="102A43"/>
+          </a:solidFill>
+          <a:ln>
+            <a:noFill/>
+          </a:ln>
+        </p:spPr>
+        <p:style>
+          <a:lnRef idx="1">
+            <a:schemeClr val="accent1"/>
+          </a:lnRef>
+          <a:fillRef idx="3">
+            <a:schemeClr val="accent1"/>
+          </a:fillRef>
+          <a:effectRef idx="2">
+            <a:schemeClr val="accent1"/>
+          </a:effectRef>
+          <a:fontRef idx="minor">
+            <a:schemeClr val="lt1"/>
+          </a:fontRef>
+        </p:style>
+        <p:txBody>
+          <a:bodyPr rtlCol="0" anchor="ctr"/>
+          <a:lstStyle/>
+          <a:p>
+            <a:pPr algn="ctr"/>
+          </a:p>
+        </p:txBody>
+      </p:sp>
+      <p:sp>
+        <p:nvSpPr>
+          <p:cNvPr id="5" name="TextBox 4"/>
+          <p:cNvSpPr txBox="1"/>
+          <p:nvPr/>
+        </p:nvSpPr>
+        <p:spPr>
+          <a:xfrm>
+            <a:off x="11073384" y="6437376"/>
+            <a:ext cx="585216" cy="182880"/>
+          </a:xfrm>
+          <a:prstGeom prst="rect">
+            <a:avLst/>
+          </a:prstGeom>
+          <a:noFill/>
+        </p:spPr>
+        <p:txBody>
+          <a:bodyPr wrap="square">
+            <a:spAutoFit/>
+          </a:bodyPr>
+          <a:lstStyle/>
+          <a:p>
+            <a:pPr>
+              <a:spcAft>
+                <a:spcPts val="0"/>
+              </a:spcAft>
+            </a:pPr>
+            <a:r>
+              <a:rPr sz="800" b="0">
+                <a:solidFill>
+                  <a:srgbClr val="5C7084"/>
+                </a:solidFill>
+                <a:latin typeface="Aptos"/>
+              </a:rPr>
+              <a:t>18</a:t>
+            </a:r>
+          </a:p>
+        </p:txBody>
+      </p:sp>
+      <p:sp>
+        <p:nvSpPr>
+          <p:cNvPr id="6" name="TextBox 5"/>
+          <p:cNvSpPr txBox="1"/>
+          <p:nvPr/>
+        </p:nvSpPr>
+        <p:spPr>
+          <a:xfrm>
+            <a:off x="640080" y="1600200"/>
+            <a:ext cx="10881360" cy="4480560"/>
+          </a:xfrm>
+          <a:prstGeom prst="rect">
+            <a:avLst/>
+          </a:prstGeom>
+          <a:noFill/>
+        </p:spPr>
+        <p:txBody>
+          <a:bodyPr wrap="square">
+            <a:spAutoFit/>
+          </a:bodyPr>
+          <a:lstStyle/>
+          <a:p>
+            <a:pPr>
+              <a:spcAft>
+                <a:spcPts val="1000"/>
+              </a:spcAft>
+            </a:pPr>
+            <a:r>
+              <a:rPr sz="1400" b="0">
+                <a:solidFill>
+                  <a:srgbClr val="16324F"/>
+                </a:solidFill>
+                <a:latin typeface="Aptos"/>
+              </a:rPr>
+              <a:t>INPUT - one labelled session (2026-09-04): calibration sweep, six stationary viewpoints, one measured 617.5 mm A→B→A move.</a:t>
+            </a:r>
+          </a:p>
+          <a:p>
+            <a:pPr>
+              <a:spcAft>
+                <a:spcPts val="1000"/>
+              </a:spcAft>
+            </a:pPr>
+            <a:r>
+              <a:rPr sz="1400" b="0">
+                <a:solidFill>
+                  <a:srgbClr val="16324F"/>
+                </a:solidFill>
+                <a:latin typeface="Aptos"/>
+              </a:rPr>
+              <a:t>STARTUP REST - every start/step/threshold/checks/fallback combination is replayed on sliding trials of the recordings. Hard gates: ≥95% of stationary trials must confirm and ≤5% of moving trials may falsely confirm. Survivors ranked by error against the reference pose and by confirmation speed.  →  30 / step 3 / 1.5 mm / 1.0° / 4 checks / fallback 100.</a:t>
+            </a:r>
+          </a:p>
+          <a:p>
+            <a:pPr>
+              <a:spcAft>
+                <a:spcPts val="1000"/>
+              </a:spcAft>
+            </a:pPr>
+            <a:r>
+              <a:rPr sz="1400" b="0">
+                <a:solidFill>
+                  <a:srgbClr val="16324F"/>
+                </a:solidFill>
+                <a:latin typeface="Aptos"/>
+              </a:rPr>
+              <a:t>DISPLAY FILTER - two coordinate-descent passes over the groups (window+radius, dead zones+smoothing, prior, endpoint+re-anchor floor, timeout): every candidate is replayed end-to-end and scored half on stationary stability (wobble, jump, drift vs raw) and half on movement (amplitude retained, delay, endpoint error, return error).  →  window 5 • radius 0.20 m • 20 mm / 0.3° • 1.2 s • 2 s • 40 mm / 3°.</a:t>
+            </a:r>
+          </a:p>
+          <a:p>
+            <a:pPr>
+              <a:spcAft>
+                <a:spcPts val="1000"/>
+              </a:spcAft>
+            </a:pPr>
+            <a:r>
+              <a:rPr sz="1400" b="1">
+                <a:solidFill>
+                  <a:srgbClr val="16324F"/>
+                </a:solidFill>
+                <a:latin typeface="Aptos"/>
+              </a:rPr>
+              <a:t>WINNER VALIDATION - movement retained 99.7% • endpoint error 4.8 mm • return error 10.4 mm.</a:t>
+            </a:r>
+          </a:p>
+          <a:p>
+            <a:pPr>
+              <a:spcAft>
+                <a:spcPts val="0"/>
+              </a:spcAft>
+            </a:pPr>
+            <a:r>
+              <a:rPr sz="1300" b="0">
+                <a:solidFill>
+                  <a:srgbClr val="5C7084"/>
+                </a:solidFill>
+                <a:latin typeface="Aptos"/>
+              </a:rPr>
+              <a:t>WEAK EVIDENCE REMAINS - tracking timeout (needs a labelled loss recording) and the 10-30 mm small-move band (the session contained only one large move).</a:t>
+            </a:r>
+          </a:p>
+        </p:txBody>
+      </p:sp>
+      <p:sp>
+        <p:nvSpPr>
+          <p:cNvPr id="7" name="TextBox 6"/>
+          <p:cNvSpPr txBox="1"/>
+          <p:nvPr/>
+        </p:nvSpPr>
+        <p:spPr>
+          <a:xfrm>
+            <a:off x="530352" y="6473952"/>
+            <a:ext cx="9784080" cy="182880"/>
+          </a:xfrm>
+          <a:prstGeom prst="rect">
+            <a:avLst/>
+          </a:prstGeom>
+          <a:noFill/>
+        </p:spPr>
+        <p:txBody>
+          <a:bodyPr wrap="square">
+            <a:spAutoFit/>
+          </a:bodyPr>
+          <a:lstStyle/>
+          <a:p>
+            <a:pPr>
+              <a:spcAft>
+                <a:spcPts val="0"/>
+              </a:spcAft>
+            </a:pPr>
+            <a:r>
+              <a:rPr sz="800" b="0">
+                <a:solidFill>
+                  <a:srgbClr val="5C7084"/>
+                </a:solidFill>
+                <a:latin typeface="Aptos"/>
+              </a:rPr>
+              <a:t>tune_filter.py • winner in tune_filter_best.txt • every evaluated configuration in tune_filter_results.csv</a:t>
+            </a:r>
+          </a:p>
+        </p:txBody>
+      </p:sp>
+    </p:spTree>
+  </p:cSld>
+  <p:clrMapOvr>
+    <a:masterClrMapping/>
+  </p:clrMapOvr>
+</p:sld>
+</file>
+
 <file path=ppt/slides/slide2.xml><?xml version="1.0" encoding="utf-8"?>
 <p:sld xmlns:a="http://schemas.openxmlformats.org/drawingml/2006/main" xmlns:r="http://schemas.openxmlformats.org/officeDocument/2006/relationships" xmlns:p="http://schemas.openxmlformats.org/presentationml/2006/main">
   <p:cSld>
@@ -13030,7 +13726,7 @@
         </p:nvSpPr>
         <p:spPr>
           <a:xfrm>
-            <a:off x="685800" y="3200400"/>
+            <a:off x="685800" y="3254676"/>
             <a:ext cx="1905000" cy="685800"/>
           </a:xfrm>
           <a:prstGeom prst="roundRect">
@@ -13521,6 +14217,36 @@
           </a:p>
         </p:txBody>
       </p:sp>
+      <p:pic>
+        <p:nvPicPr>
+          <p:cNvPr id="13" name="Picture 12">
+            <a:extLst>
+              <a:ext uri="{FF2B5EF4-FFF2-40B4-BE49-F238E27FC236}">
+                <a16:creationId xmlns:a16="http://schemas.microsoft.com/office/drawing/2014/main" id="{571A4E33-939E-8183-78B3-EC694EE0EC25}"/>
+              </a:ext>
+            </a:extLst>
+          </p:cNvPr>
+          <p:cNvPicPr>
+            <a:picLocks noChangeAspect="1"/>
+          </p:cNvPicPr>
+          <p:nvPr/>
+        </p:nvPicPr>
+        <p:blipFill>
+          <a:blip r:embed="rId2"/>
+          <a:stretch>
+            <a:fillRect/>
+          </a:stretch>
+        </p:blipFill>
+        <p:spPr>
+          <a:xfrm>
+            <a:off x="8153400" y="5287403"/>
+            <a:ext cx="4018856" cy="1536193"/>
+          </a:xfrm>
+          <a:prstGeom prst="rect">
+            <a:avLst/>
+          </a:prstGeom>
+        </p:spPr>
+      </p:pic>
     </p:spTree>
     <p:extLst>
       <p:ext uri="{BB962C8B-B14F-4D97-AF65-F5344CB8AC3E}">
@@ -14321,7 +15047,25 @@
                 </a:solidFill>
                 <a:latin typeface="Aptos" panose="020B0004020202020204" pitchFamily="34" charset="0"/>
               </a:rPr>
-              <a:t>Each estimate uses coordinate-median position + one measured rotation medoid over all collected poses.</a:t>
+              <a:t>Each estimate uses </a:t>
+            </a:r>
+            <a:r>
+              <a:rPr lang="en-GB" sz="1600" dirty="0">
+                <a:solidFill>
+                  <a:srgbClr val="FF0000"/>
+                </a:solidFill>
+                <a:latin typeface="Aptos" panose="020B0004020202020204" pitchFamily="34" charset="0"/>
+              </a:rPr>
+              <a:t>coordinate-median position + one measured rotation medoid </a:t>
+            </a:r>
+            <a:r>
+              <a:rPr lang="en-GB" sz="1600" dirty="0">
+                <a:solidFill>
+                  <a:srgbClr val="16324F"/>
+                </a:solidFill>
+                <a:latin typeface="Aptos" panose="020B0004020202020204" pitchFamily="34" charset="0"/>
+              </a:rPr>
+              <a:t>over all collected poses.</a:t>
             </a:r>
           </a:p>
         </p:txBody>
@@ -14463,23 +15207,6 @@
                 <a:latin typeface="Aptos" panose="020B0004020202020204" pitchFamily="34" charset="0"/>
               </a:rPr>
               <a:t>4 stable comparisons → detection 42 earliest</a:t>
-            </a:r>
-            <a:br>
-              <a:rPr lang="en-GB" sz="1500" b="1" dirty="0">
-                <a:solidFill>
-                  <a:srgbClr val="202C37"/>
-                </a:solidFill>
-                <a:latin typeface="Aptos" panose="020B0004020202020204" pitchFamily="34" charset="0"/>
-              </a:rPr>
-            </a:br>
-            <a:r>
-              <a:rPr lang="en-GB" sz="1500" b="1" dirty="0">
-                <a:solidFill>
-                  <a:srgbClr val="202C37"/>
-                </a:solidFill>
-                <a:latin typeface="Aptos" panose="020B0004020202020204" pitchFamily="34" charset="0"/>
-              </a:rPr>
-              <a:t/>
             </a:r>
             <a:br>
               <a:rPr lang="en-GB" sz="1500" b="1" dirty="0">
@@ -15791,7 +16518,7 @@
         <p:spPr>
           <a:xfrm>
             <a:off x="7467600" y="4025900"/>
-            <a:ext cx="2540000" cy="430887"/>
+            <a:ext cx="2540000" cy="215444"/>
           </a:xfrm>
           <a:prstGeom prst="rect">
             <a:avLst/>
@@ -15812,7 +16539,7 @@
                 </a:solidFill>
                 <a:latin typeface="Aptos" panose="020B0004020202020204" pitchFamily="34" charset="0"/>
               </a:rPr>
-              <a:t>Moves continuously at render rate</a:t>
+              <a:t>Moves continuously</a:t>
             </a:r>
           </a:p>
         </p:txBody>
@@ -15832,7 +16559,7 @@
         <p:spPr>
           <a:xfrm>
             <a:off x="9766300" y="4025900"/>
-            <a:ext cx="1905000" cy="430887"/>
+            <a:ext cx="1905000" cy="215444"/>
           </a:xfrm>
           <a:prstGeom prst="rect">
             <a:avLst/>
@@ -15847,13 +16574,13 @@
           <a:p>
             <a:pPr algn="ctr"/>
             <a:r>
-              <a:rPr lang="en-GB" sz="1400">
+              <a:rPr lang="en-GB" sz="1400" dirty="0">
                 <a:solidFill>
                   <a:srgbClr val="5C7084"/>
                 </a:solidFill>
                 <a:latin typeface="Aptos" panose="020B0004020202020204" pitchFamily="34" charset="0"/>
               </a:rPr>
-              <a:t>Always active; measurement leads</a:t>
+              <a:t>Always active; </a:t>
             </a:r>
           </a:p>
         </p:txBody>
@@ -15872,8 +16599,8 @@
         </p:nvSpPr>
         <p:spPr>
           <a:xfrm>
-            <a:off x="1193800" y="5207000"/>
-            <a:ext cx="9804400" cy="698500"/>
+            <a:off x="1193800" y="5115560"/>
+            <a:ext cx="9804400" cy="868680"/>
           </a:xfrm>
           <a:prstGeom prst="roundRect">
             <a:avLst/>
@@ -15909,7 +16636,7 @@
           <a:p>
             <a:pPr algn="ctr"/>
             <a:r>
-              <a:rPr lang="en-GB" sz="1600" b="1" dirty="0">
+              <a:rPr lang="en-GB" sz="1400" b="1" dirty="0">
                 <a:solidFill>
                   <a:srgbClr val="FFFFFF"/>
                 </a:solidFill>
@@ -16785,15 +17512,6 @@
                 <a:latin typeface="Aptos" panose="020B0004020202020204" pitchFamily="34" charset="0"/>
               </a:rPr>
             </a:br>
-            <a:r>
-              <a:rPr lang="en-GB" sz="1600">
-                <a:solidFill>
-                  <a:srgbClr val="16324F"/>
-                </a:solidFill>
-                <a:latin typeface="Aptos" panose="020B0004020202020204" pitchFamily="34" charset="0"/>
-              </a:rPr>
-              <a:t/>
-            </a:r>
             <a:br>
               <a:rPr lang="en-GB" sz="1600">
                 <a:solidFill>
@@ -17227,15 +17945,6 @@
                 <a:latin typeface="Aptos" panose="020B0004020202020204" pitchFamily="34" charset="0"/>
               </a:rPr>
             </a:br>
-            <a:r>
-              <a:rPr lang="en-GB" sz="1600">
-                <a:solidFill>
-                  <a:srgbClr val="16324F"/>
-                </a:solidFill>
-                <a:latin typeface="Aptos" panose="020B0004020202020204" pitchFamily="34" charset="0"/>
-              </a:rPr>
-              <a:t/>
-            </a:r>
             <a:br>
               <a:rPr lang="en-GB" sz="1600">
                 <a:solidFill>
@@ -17385,15 +18094,6 @@
                 <a:latin typeface="Aptos" panose="020B0004020202020204" pitchFamily="34" charset="0"/>
               </a:rPr>
             </a:br>
-            <a:r>
-              <a:rPr lang="el-GR" sz="1600" dirty="0">
-                <a:solidFill>
-                  <a:srgbClr val="16324F"/>
-                </a:solidFill>
-                <a:latin typeface="Aptos" panose="020B0004020202020204" pitchFamily="34" charset="0"/>
-              </a:rPr>
-              <a:t/>
-            </a:r>
             <a:br>
               <a:rPr lang="el-GR" sz="1600" dirty="0">
                 <a:solidFill>
@@ -17566,15 +18266,6 @@
                 <a:latin typeface="Aptos" panose="020B0004020202020204" pitchFamily="34" charset="0"/>
               </a:rPr>
             </a:br>
-            <a:r>
-              <a:rPr lang="en-GB" sz="1600" dirty="0">
-                <a:solidFill>
-                  <a:srgbClr val="16324F"/>
-                </a:solidFill>
-                <a:latin typeface="Aptos" panose="020B0004020202020204" pitchFamily="34" charset="0"/>
-              </a:rPr>
-              <a:t/>
-            </a:r>
             <a:br>
               <a:rPr lang="en-GB" sz="1600" dirty="0">
                 <a:solidFill>

</xml_diff>

<commit_message>
Rebuild re-anchor slide as full six-phase story; fix remaining 7-pose refs
Co-Authored-By: Claude Fable 5 <noreply@anthropic.com>
</commit_message>
<xml_diff>
--- a/docs/Quest_Avatar_Placement_Algorithm_NaReT_Current_2026-09-05.pptx
+++ b/docs/Quest_Avatar_Placement_Algorithm_NaReT_Current_2026-09-05.pptx
@@ -11835,45 +11835,6 @@
       </p:sp>
       <p:sp>
         <p:nvSpPr>
-          <p:cNvPr id="3" name="TextBox 2"/>
-          <p:cNvSpPr txBox="1"/>
-          <p:nvPr/>
-        </p:nvSpPr>
-        <p:spPr>
-          <a:xfrm>
-            <a:off x="530352" y="530352"/>
-            <a:ext cx="10981944" cy="502920"/>
-          </a:xfrm>
-          <a:prstGeom prst="rect">
-            <a:avLst/>
-          </a:prstGeom>
-          <a:noFill/>
-        </p:spPr>
-        <p:txBody>
-          <a:bodyPr wrap="square">
-            <a:spAutoFit/>
-          </a:bodyPr>
-          <a:lstStyle/>
-          <a:p>
-            <a:pPr>
-              <a:spcAft>
-                <a:spcPts val="0"/>
-              </a:spcAft>
-            </a:pPr>
-            <a:r>
-              <a:rPr sz="2400" b="1">
-                <a:solidFill>
-                  <a:srgbClr val="102A43"/>
-                </a:solidFill>
-                <a:latin typeface="Aptos"/>
-              </a:rPr>
-              <a:t>How a re-anchor happens - the exact chain</a:t>
-            </a:r>
-          </a:p>
-        </p:txBody>
-      </p:sp>
-      <p:sp>
-        <p:nvSpPr>
           <p:cNvPr id="4" name="Rectangle 3"/>
           <p:cNvSpPr/>
           <p:nvPr/>
@@ -11962,8 +11923,8 @@
         </p:nvSpPr>
         <p:spPr>
           <a:xfrm>
-            <a:off x="640080" y="1600200"/>
-            <a:ext cx="10881360" cy="3017520"/>
+            <a:off x="530352" y="530352"/>
+            <a:ext cx="10981944" cy="502920"/>
           </a:xfrm>
           <a:prstGeom prst="rect">
             <a:avLst/>
@@ -11975,70 +11936,6 @@
             <a:spAutoFit/>
           </a:bodyPr>
           <a:lstStyle/>
-          <a:p>
-            <a:pPr>
-              <a:spcAft>
-                <a:spcPts val="800"/>
-              </a:spcAft>
-            </a:pPr>
-            <a:r>
-              <a:rPr sz="1500" b="0">
-                <a:solidFill>
-                  <a:srgbClr val="16324F"/>
-                </a:solidFill>
-                <a:latin typeface="Aptos"/>
-              </a:rPr>
-              <a:t>1.  Every detection produces one fused, floor-locked pose.</a:t>
-            </a:r>
-          </a:p>
-          <a:p>
-            <a:pPr>
-              <a:spcAft>
-                <a:spcPts val="800"/>
-              </a:spcAft>
-            </a:pPr>
-            <a:r>
-              <a:rPr sz="1500" b="0">
-                <a:solidFill>
-                  <a:srgbClr val="16324F"/>
-                </a:solidFill>
-                <a:latin typeface="Aptos"/>
-              </a:rPr>
-              <a:t>2.  The window of the last 5 poses keeps a running MEDOID - one real measured pose, the most central. This measurement target is the markers' pure, unfiltered opinion: no dead zone, no smoothing, no prior.</a:t>
-            </a:r>
-          </a:p>
-          <a:p>
-            <a:pPr>
-              <a:spcAft>
-                <a:spcPts val="800"/>
-              </a:spcAft>
-            </a:pPr>
-            <a:r>
-              <a:rPr sz="1500" b="0">
-                <a:solidFill>
-                  <a:srgbClr val="16324F"/>
-                </a:solidFill>
-                <a:latin typeface="Aptos"/>
-              </a:rPr>
-              <a:t>3.  SETTLED test: the last 3 consecutive targets must all agree within 1.5 mm / 1.0° of the newest one - movement has provably stopped.</a:t>
-            </a:r>
-          </a:p>
-          <a:p>
-            <a:pPr>
-              <a:spcAft>
-                <a:spcPts val="800"/>
-              </a:spcAft>
-            </a:pPr>
-            <a:r>
-              <a:rPr sz="1500" b="0">
-                <a:solidFill>
-                  <a:srgbClr val="16324F"/>
-                </a:solidFill>
-                <a:latin typeface="Aptos"/>
-              </a:rPr>
-              <a:t>4.  DISTANCE test: the settled target must lie beyond 40 mm / 3° from the remembered rest - too far to be viewpoint bias.</a:t>
-            </a:r>
-          </a:p>
           <a:p>
             <a:pPr>
               <a:spcAft>
@@ -12046,27 +11943,146 @@
               </a:spcAft>
             </a:pPr>
             <a:r>
-              <a:rPr sz="1500" b="0">
+              <a:rPr sz="2400" b="1">
+                <a:solidFill>
+                  <a:srgbClr val="102A43"/>
+                </a:solidFill>
+                <a:latin typeface="Aptos"/>
+              </a:rPr>
+              <a:t>Re-anchoring - the full story of a mannequin move</a:t>
+            </a:r>
+          </a:p>
+        </p:txBody>
+      </p:sp>
+      <p:sp>
+        <p:nvSpPr>
+          <p:cNvPr id="7" name="TextBox 6"/>
+          <p:cNvSpPr txBox="1"/>
+          <p:nvPr/>
+        </p:nvSpPr>
+        <p:spPr>
+          <a:xfrm>
+            <a:off x="640080" y="1389888"/>
+            <a:ext cx="10881360" cy="3566160"/>
+          </a:xfrm>
+          <a:prstGeom prst="rect">
+            <a:avLst/>
+          </a:prstGeom>
+          <a:noFill/>
+        </p:spPr>
+        <p:txBody>
+          <a:bodyPr wrap="square">
+            <a:spAutoFit/>
+          </a:bodyPr>
+          <a:lstStyle/>
+          <a:p>
+            <a:pPr>
+              <a:spcAft>
+                <a:spcPts val="600"/>
+              </a:spcAft>
+            </a:pPr>
+            <a:r>
+              <a:rPr sz="1250" b="0">
                 <a:solidFill>
                   <a:srgbClr val="16324F"/>
                 </a:solidFill>
                 <a:latin typeface="Aptos"/>
               </a:rPr>
-              <a:t>5.  Both passed → the newest medoid target becomes the new rest, copied verbatim. Position and rotation re-anchor independently, once per detection.</a:t>
-            </a:r>
-          </a:p>
-        </p:txBody>
-      </p:sp>
-      <p:sp>
-        <p:nvSpPr>
-          <p:cNvPr id="7" name="Rounded Rectangle 6"/>
+              <a:t>0.  AT REST - the avatar sits pinned at the remembered rest R. Measurements jitter a few millimetres; the dead zone hides it and the prior (τ = 2 s) holds the avatar at R. Every detection still updates the 5-pose medoid target.</a:t>
+            </a:r>
+          </a:p>
+          <a:p>
+            <a:pPr>
+              <a:spcAft>
+                <a:spcPts val="600"/>
+              </a:spcAft>
+            </a:pPr>
+            <a:r>
+              <a:rPr sz="1250" b="0">
+                <a:solidFill>
+                  <a:srgbClr val="16324F"/>
+                </a:solidFill>
+                <a:latin typeface="Aptos"/>
+              </a:rPr>
+              <a:t>1.  THE MANNEQUIN IS MOVED - the markers report the new position; the medoid target follows within ~5 detections. The display chases it smoothly (τ = 1.2 s) while the prior still leans slightly toward the old R.</a:t>
+            </a:r>
+          </a:p>
+          <a:p>
+            <a:pPr>
+              <a:spcAft>
+                <a:spcPts val="600"/>
+              </a:spcAft>
+            </a:pPr>
+            <a:r>
+              <a:rPr sz="1250" b="0">
+                <a:solidFill>
+                  <a:srgbClr val="16324F"/>
+                </a:solidFill>
+                <a:latin typeface="Aptos"/>
+              </a:rPr>
+              <a:t>2.  MOVEMENT STOPS - the targets cluster. SETTLED test: the last 3 targets all lie within 1.5 mm / 1.0° of the newest one → the move has provably ended.</a:t>
+            </a:r>
+          </a:p>
+          <a:p>
+            <a:pPr>
+              <a:spcAft>
+                <a:spcPts val="600"/>
+              </a:spcAft>
+            </a:pPr>
+            <a:r>
+              <a:rPr sz="1250" b="0">
+                <a:solidFill>
+                  <a:srgbClr val="16324F"/>
+                </a:solidFill>
+                <a:latin typeface="Aptos"/>
+              </a:rPr>
+              <a:t>3.  REAL OR BIAS? - DISTANCE test: the settled target sits more than 40 mm / 3° from the old R → too large to be viewpoint bias → a genuine relocation. (Smaller settled offsets are treated as bias and never move R.)</a:t>
+            </a:r>
+          </a:p>
+          <a:p>
+            <a:pPr>
+              <a:spcAft>
+                <a:spcPts val="600"/>
+              </a:spcAft>
+            </a:pPr>
+            <a:r>
+              <a:rPr sz="1250" b="0">
+                <a:solidFill>
+                  <a:srgbClr val="16324F"/>
+                </a:solidFill>
+                <a:latin typeface="Aptos"/>
+              </a:rPr>
+              <a:t>4.  RE-ANCHOR - the newest medoid target becomes the new R, copied verbatim, in one invisible internal step. Position and rotation update independently. The viewer sees nothing: only the internal anchor jumps.</a:t>
+            </a:r>
+          </a:p>
+          <a:p>
+            <a:pPr>
+              <a:spcAft>
+                <a:spcPts val="0"/>
+              </a:spcAft>
+            </a:pPr>
+            <a:r>
+              <a:rPr sz="1250" b="0">
+                <a:solidFill>
+                  <a:srgbClr val="16324F"/>
+                </a:solidFill>
+                <a:latin typeface="Aptos"/>
+              </a:rPr>
+              <a:t>5.  LANDING - target and R now agree, so the dead zone yields and the display closes the final millimetres onto the new R at smoothing speed. The prior now holds the avatar at the NEW home - back to phase 0.</a:t>
+            </a:r>
+          </a:p>
+        </p:txBody>
+      </p:sp>
+      <p:sp>
+        <p:nvSpPr>
+          <p:cNvPr id="8" name="Rounded Rectangle 7"/>
           <p:cNvSpPr/>
           <p:nvPr/>
         </p:nvSpPr>
         <p:spPr>
           <a:xfrm>
-            <a:off x="822960" y="4892040"/>
-            <a:ext cx="10515600" cy="1234440"/>
+            <a:off x="822960" y="5212080"/>
+            <a:ext cx="10515600" cy="1051560"/>
           </a:xfrm>
           <a:prstGeom prst="roundRect">
             <a:avLst/>
@@ -12100,20 +12116,20 @@
           <a:p>
             <a:pPr algn="ctr"/>
             <a:r>
-              <a:rPr sz="1300">
+              <a:rPr sz="1250">
                 <a:solidFill>
                   <a:srgbClr val="16324F"/>
                 </a:solidFill>
                 <a:latin typeface="Aptos"/>
               </a:rPr>
-              <a:t>What the new rest deliberately is NOT: not the displayed pose (it contains smoothing and prior feedback - learning from it would be a feedback loop); not a single raw detection (glitch risk); not an average of the settled window (only one real measured pose is ever adopted).</a:t>
-            </a:r>
-          </a:p>
-        </p:txBody>
-      </p:sp>
-      <p:sp>
-        <p:nvSpPr>
-          <p:cNvPr id="8" name="TextBox 7"/>
+              <a:t>R never learns from the displayed pose (that would be a feedback loop), from a single raw detection (glitch risk), or from an average (only one real measured pose is ever adopted). Between re-anchors, R is completely frozen.</a:t>
+            </a:r>
+          </a:p>
+        </p:txBody>
+      </p:sp>
+      <p:sp>
+        <p:nvSpPr>
+          <p:cNvPr id="9" name="TextBox 8"/>
           <p:cNvSpPr txBox="1"/>
           <p:nvPr/>
         </p:nvSpPr>
@@ -12145,7 +12161,7 @@
                 </a:solidFill>
                 <a:latin typeface="Aptos"/>
               </a:rPr>
-              <a:t>navel_provider.gd::reanchor_rest_from_stable_target • SimplePoseStabilizer.measurement_target()</a:t>
+              <a:t>navel_provider.gd::reanchor_rest_from_stable_target • SimplePoseStabilizer.measurement_target() • landing in _landing_position</a:t>
             </a:r>
           </a:p>
         </p:txBody>
@@ -18668,7 +18684,7 @@
                 </a:solidFill>
                 <a:latin typeface="Aptos" panose="020B0004020202020204" pitchFamily="34" charset="0"/>
               </a:rPr>
-              <a:t>7-pose medoid</a:t>
+              <a:t>5-pose medoid</a:t>
             </a:r>
           </a:p>
         </p:txBody>
@@ -19665,7 +19681,7 @@
                 </a:solidFill>
                 <a:latin typeface="Aptos" panose="020B0004020202020204" pitchFamily="34" charset="0"/>
               </a:rPr>
-              <a:t>Collect 7 fresh detections</a:t>
+              <a:t>Collect 5 fresh detections</a:t>
             </a:r>
             <a:br>
               <a:rPr lang="en-GB" sz="1500" b="1" dirty="0">
@@ -19675,6 +19691,15 @@
                 <a:latin typeface="Aptos" panose="020B0004020202020204" pitchFamily="34" charset="0"/>
               </a:rPr>
             </a:br>
+            <a:r>
+              <a:rPr lang="en-GB" sz="1500" b="1" dirty="0">
+                <a:solidFill>
+                  <a:srgbClr val="FFFFFF"/>
+                </a:solidFill>
+                <a:latin typeface="Aptos" panose="020B0004020202020204" pitchFamily="34" charset="0"/>
+              </a:rPr>
+              <a:t>≈0.5 s at 10 Hz</a:t>
+            </a:r>
             <a:endParaRPr lang="en-GB" sz="1500" b="1" dirty="0">
               <a:solidFill>
                 <a:srgbClr val="FFFFFF"/>

</xml_diff>